<commit_message>
Add representative aggregation methods to profile map
</commit_message>
<xml_diff>
--- a/assets/temporal-representation.pptx
+++ b/assets/temporal-representation.pptx
@@ -2,13 +2,13 @@
 <file path=ppt/presentation.xml><?xml version="1.0" encoding="utf-8"?>
 <p:presentation xmlns:p="http://schemas.openxmlformats.org/presentationml/2006/main">
   <p:sldMasterIdLst>
-    <p:sldMasterId xmlns:r="http://schemas.openxmlformats.org/officeDocument/2006/relationships" id="2147483648" r:id="R7a1fb34ff18040b0"/>
+    <p:sldMasterId xmlns:r="http://schemas.openxmlformats.org/officeDocument/2006/relationships" id="2147483648" r:id="R57be7c9ba07f4148"/>
   </p:sldMasterIdLst>
   <p:notesMasterIdLst>
-    <p:notesMasterId xmlns:r="http://schemas.openxmlformats.org/officeDocument/2006/relationships" r:id="R4debc689fc534f68"/>
+    <p:notesMasterId xmlns:r="http://schemas.openxmlformats.org/officeDocument/2006/relationships" r:id="R8e5705abf1044cd6"/>
   </p:notesMasterIdLst>
   <p:sldIdLst>
-    <p:sldId xmlns:r="http://schemas.openxmlformats.org/officeDocument/2006/relationships" id="256" r:id="R0ff596a262604f1d"/>
+    <p:sldId xmlns:r="http://schemas.openxmlformats.org/officeDocument/2006/relationships" id="256" r:id="R4ea6003a747a4fdf"/>
   </p:sldIdLst>
   <p:sldSz cx="12192000" cy="6858000"/>
   <p:notesSz cx="6858000" cy="9144000"/>
@@ -442,7 +442,7 @@
           <a:lstStyle xmlns:a="http://schemas.openxmlformats.org/drawingml/2006/main"/>
           <a:p xmlns:a="http://schemas.openxmlformats.org/drawingml/2006/main">
             <a:r>
-              <a:t>Research directions supplied by Zipeng Wu. Temporal Representation is the umbrella term. Connections show research relationships, not a fixed processing pipeline. Frequency conversion retains the broad wording supplied by the author. Classification is current work. Project context: https://zipengwu365.github.io/research.html ; https://systems-mechanobiology.github.io/DeTime/ ; https://github.com/ZipengWu365/TSDecompose-Benchmark ; https://zipengwu365.github.io/EchoTime/ .</a:t>
+              <a:t>Research directions supplied by Zipeng Wu. Temporal Representation is the umbrella term. Connections show research relationships, not a fixed processing pipeline. Frequency conversion retains the broad wording supplied by the author. Classification is current work. PAA, SAX, and SAA-SAX are representative methods from the literature, not works attributed to Zipeng Wu. PAA represents segments by their means. SAX discretizes PAA values into symbols. SAA-SAX uses slope-based aggregation before discretization. References: Lin et al., A Symbolic Representation of Time Series, with Implications for Streaming Algorithms (2003), https://www.cs.ucr.edu/~stelo/papers/DMKD03.pdf ; Pappa et al., Slopewise Aggregate Approximation SAX: keeping the trend of a time series (2021), https://doi.org/10.1109/SSCI50451.2021.9660130 . Project context: https://zipengwu365.github.io/research.html ; https://systems-mechanobiology.github.io/DeTime/ ; https://github.com/ZipengWu365/TSDecompose-Benchmark ; https://zipengwu365.github.io/EchoTime/ .</a:t>
             </a:r>
           </a:p>
         </p:txBody>
@@ -510,7 +510,7 @@
   </p:cSld>
   <p:clrMap bg1="lt1" tx1="dk1" bg2="lt2" tx2="dk2" accent1="accent1" accent2="accent2" accent3="accent3" accent4="accent4" accent5="accent5" accent6="accent6" hlink="hlink" folHlink="folHlink"/>
   <p:sldLayoutIdLst>
-    <p:sldLayoutId xmlns:r="http://schemas.openxmlformats.org/officeDocument/2006/relationships" id="2147483649" r:id="R19baa68bea8c49e4"/>
+    <p:sldLayoutId xmlns:r="http://schemas.openxmlformats.org/officeDocument/2006/relationships" id="2147483649" r:id="Rbe3b0827449145cd"/>
   </p:sldLayoutIdLst>
   <p:txStyles>
     <p:titleStyle>
@@ -1058,10 +1058,10 @@
       </p:grpSpPr>
       <p:sp>
         <p:nvSpPr>
-          <p:cNvPr id="35" name="left-branch">
-            <a:extLst xmlns:a="http://schemas.openxmlformats.org/drawingml/2006/main">
-              <a:ext uri="{FF2B5EF4-FFF2-40B4-BE49-F238E27FC236}">
-                <a16:creationId xmlns:a16="http://schemas.microsoft.com/office/drawing/2014/main" id="{E54A11BB-4053-421E-9AE3-FD3DDEF012EA}"/>
+          <p:cNvPr id="38" name="left-branch">
+            <a:extLst xmlns:a="http://schemas.openxmlformats.org/drawingml/2006/main">
+              <a:ext uri="{FF2B5EF4-FFF2-40B4-BE49-F238E27FC236}">
+                <a16:creationId xmlns:a16="http://schemas.microsoft.com/office/drawing/2014/main" id="{C713CFBE-9CC0-4CCE-B3F2-26E94CACB52E}"/>
               </a:ext>
             </a:extLst>
           </p:cNvPr>
@@ -1092,7 +1092,7 @@
           <p:cNvPr id="2" name="right-branch">
             <a:extLst xmlns:a="http://schemas.openxmlformats.org/drawingml/2006/main">
               <a:ext uri="{FF2B5EF4-FFF2-40B4-BE49-F238E27FC236}">
-                <a16:creationId xmlns:a16="http://schemas.microsoft.com/office/drawing/2014/main" id="{2040461A-CCA9-42D3-9A0F-77ACD6FEBE47}"/>
+                <a16:creationId xmlns:a16="http://schemas.microsoft.com/office/drawing/2014/main" id="{09F00097-5052-48AE-A748-47D9E7F19174}"/>
               </a:ext>
             </a:extLst>
           </p:cNvPr>
@@ -1123,7 +1123,7 @@
           <p:cNvPr id="3" name="left-core-connection">
             <a:extLst xmlns:a="http://schemas.openxmlformats.org/drawingml/2006/main">
               <a:ext uri="{FF2B5EF4-FFF2-40B4-BE49-F238E27FC236}">
-                <a16:creationId xmlns:a16="http://schemas.microsoft.com/office/drawing/2014/main" id="{FC1ECE75-892E-4C8D-9A39-17A47FA1AEA9}"/>
+                <a16:creationId xmlns:a16="http://schemas.microsoft.com/office/drawing/2014/main" id="{F2A310FA-0324-4919-891D-FE3FD0F0E10C}"/>
               </a:ext>
             </a:extLst>
           </p:cNvPr>
@@ -1154,7 +1154,7 @@
           <p:cNvPr id="4" name="right-core-connection">
             <a:extLst xmlns:a="http://schemas.openxmlformats.org/drawingml/2006/main">
               <a:ext uri="{FF2B5EF4-FFF2-40B4-BE49-F238E27FC236}">
-                <a16:creationId xmlns:a16="http://schemas.microsoft.com/office/drawing/2014/main" id="{766DDCCD-96B0-4E5D-864E-582A2D918893}"/>
+                <a16:creationId xmlns:a16="http://schemas.microsoft.com/office/drawing/2014/main" id="{E9BD7CEE-A2BD-4417-9D02-2B6B27B7F584}"/>
               </a:ext>
             </a:extLst>
           </p:cNvPr>
@@ -1185,7 +1185,7 @@
           <p:cNvPr id="5" name="decomposition-connection">
             <a:extLst xmlns:a="http://schemas.openxmlformats.org/drawingml/2006/main">
               <a:ext uri="{FF2B5EF4-FFF2-40B4-BE49-F238E27FC236}">
-                <a16:creationId xmlns:a16="http://schemas.microsoft.com/office/drawing/2014/main" id="{BA429826-9633-4406-A0AA-6DFDAF926729}"/>
+                <a16:creationId xmlns:a16="http://schemas.microsoft.com/office/drawing/2014/main" id="{1743FE8B-16FE-4D90-92C3-D7253781E1B0}"/>
               </a:ext>
             </a:extLst>
           </p:cNvPr>
@@ -1216,7 +1216,7 @@
           <p:cNvPr id="6" name="left-connection-0">
             <a:extLst xmlns:a="http://schemas.openxmlformats.org/drawingml/2006/main">
               <a:ext uri="{FF2B5EF4-FFF2-40B4-BE49-F238E27FC236}">
-                <a16:creationId xmlns:a16="http://schemas.microsoft.com/office/drawing/2014/main" id="{6D68E7F8-A175-4097-A38C-3497F28CAAB7}"/>
+                <a16:creationId xmlns:a16="http://schemas.microsoft.com/office/drawing/2014/main" id="{BB427F0E-A327-4310-AE58-3FB1E6D90A91}"/>
               </a:ext>
             </a:extLst>
           </p:cNvPr>
@@ -1247,7 +1247,7 @@
           <p:cNvPr id="7" name="right-connection-0">
             <a:extLst xmlns:a="http://schemas.openxmlformats.org/drawingml/2006/main">
               <a:ext uri="{FF2B5EF4-FFF2-40B4-BE49-F238E27FC236}">
-                <a16:creationId xmlns:a16="http://schemas.microsoft.com/office/drawing/2014/main" id="{B1DC064E-817D-4953-AC4D-52050E8B973D}"/>
+                <a16:creationId xmlns:a16="http://schemas.microsoft.com/office/drawing/2014/main" id="{808716AC-4E1C-4542-AFD6-1107035D89C6}"/>
               </a:ext>
             </a:extLst>
           </p:cNvPr>
@@ -1278,7 +1278,7 @@
           <p:cNvPr id="8" name="left-connection-1">
             <a:extLst xmlns:a="http://schemas.openxmlformats.org/drawingml/2006/main">
               <a:ext uri="{FF2B5EF4-FFF2-40B4-BE49-F238E27FC236}">
-                <a16:creationId xmlns:a16="http://schemas.microsoft.com/office/drawing/2014/main" id="{619C895A-28C7-4131-88B7-6EBB25DDE1FC}"/>
+                <a16:creationId xmlns:a16="http://schemas.microsoft.com/office/drawing/2014/main" id="{187C922A-349B-461A-982E-AC1D2122E51A}"/>
               </a:ext>
             </a:extLst>
           </p:cNvPr>
@@ -1309,7 +1309,7 @@
           <p:cNvPr id="9" name="right-connection-1">
             <a:extLst xmlns:a="http://schemas.openxmlformats.org/drawingml/2006/main">
               <a:ext uri="{FF2B5EF4-FFF2-40B4-BE49-F238E27FC236}">
-                <a16:creationId xmlns:a16="http://schemas.microsoft.com/office/drawing/2014/main" id="{4A3B6668-E851-40BE-A185-54DDF840E21C}"/>
+                <a16:creationId xmlns:a16="http://schemas.microsoft.com/office/drawing/2014/main" id="{B3A3DE80-BF2F-431E-99F5-DF0C58041A0B}"/>
               </a:ext>
             </a:extLst>
           </p:cNvPr>
@@ -1340,7 +1340,7 @@
           <p:cNvPr id="10" name="left-connection-2">
             <a:extLst xmlns:a="http://schemas.openxmlformats.org/drawingml/2006/main">
               <a:ext uri="{FF2B5EF4-FFF2-40B4-BE49-F238E27FC236}">
-                <a16:creationId xmlns:a16="http://schemas.microsoft.com/office/drawing/2014/main" id="{E9EA387C-7354-495F-A71F-A11354D3D822}"/>
+                <a16:creationId xmlns:a16="http://schemas.microsoft.com/office/drawing/2014/main" id="{AF14ADF6-788D-4E1F-AB5A-205B370523DE}"/>
               </a:ext>
             </a:extLst>
           </p:cNvPr>
@@ -1371,7 +1371,7 @@
           <p:cNvPr id="11" name="right-connection-2">
             <a:extLst xmlns:a="http://schemas.openxmlformats.org/drawingml/2006/main">
               <a:ext uri="{FF2B5EF4-FFF2-40B4-BE49-F238E27FC236}">
-                <a16:creationId xmlns:a16="http://schemas.microsoft.com/office/drawing/2014/main" id="{895305D6-62FC-4DFE-9D7D-63CDF07112C3}"/>
+                <a16:creationId xmlns:a16="http://schemas.microsoft.com/office/drawing/2014/main" id="{DFAA9936-ED78-473F-8793-D2B850E109C8}"/>
               </a:ext>
             </a:extLst>
           </p:cNvPr>
@@ -1402,7 +1402,7 @@
           <p:cNvPr id="12" name="temporal-representation">
             <a:extLst xmlns:a="http://schemas.openxmlformats.org/drawingml/2006/main">
               <a:ext uri="{FF2B5EF4-FFF2-40B4-BE49-F238E27FC236}">
-                <a16:creationId xmlns:a16="http://schemas.microsoft.com/office/drawing/2014/main" id="{07E61E89-EDF3-4F32-8BD9-7E1590E217E9}"/>
+                <a16:creationId xmlns:a16="http://schemas.microsoft.com/office/drawing/2014/main" id="{2E16DBB3-282E-4276-9AD8-4D9605B1D3DA}"/>
               </a:ext>
             </a:extLst>
           </p:cNvPr>
@@ -1435,7 +1435,7 @@
           <p:cNvPr id="13" name="core-label">
             <a:extLst xmlns:a="http://schemas.openxmlformats.org/drawingml/2006/main">
               <a:ext uri="{FF2B5EF4-FFF2-40B4-BE49-F238E27FC236}">
-                <a16:creationId xmlns:a16="http://schemas.microsoft.com/office/drawing/2014/main" id="{405C8219-F5D8-412F-BCF1-F71D55C28D0D}"/>
+                <a16:creationId xmlns:a16="http://schemas.microsoft.com/office/drawing/2014/main" id="{F13903FD-4371-4A78-9DC6-2CFFA8151500}"/>
               </a:ext>
             </a:extLst>
           </p:cNvPr>
@@ -1515,7 +1515,7 @@
           <p:cNvPr id="14" name="symbolic">
             <a:extLst xmlns:a="http://schemas.openxmlformats.org/drawingml/2006/main">
               <a:ext uri="{FF2B5EF4-FFF2-40B4-BE49-F238E27FC236}">
-                <a16:creationId xmlns:a16="http://schemas.microsoft.com/office/drawing/2014/main" id="{9D9E3FA8-A10D-4F32-A660-EE425C15B1DD}"/>
+                <a16:creationId xmlns:a16="http://schemas.microsoft.com/office/drawing/2014/main" id="{7E6D3CC2-014F-456B-B27F-76E4A04F9768}"/>
               </a:ext>
             </a:extLst>
           </p:cNvPr>
@@ -1548,7 +1548,7 @@
           <p:cNvPr id="15" name="symbolic-label">
             <a:extLst xmlns:a="http://schemas.openxmlformats.org/drawingml/2006/main">
               <a:ext uri="{FF2B5EF4-FFF2-40B4-BE49-F238E27FC236}">
-                <a16:creationId xmlns:a16="http://schemas.microsoft.com/office/drawing/2014/main" id="{2A683F18-B458-4890-BA76-8F35A70A2E31}"/>
+                <a16:creationId xmlns:a16="http://schemas.microsoft.com/office/drawing/2014/main" id="{4BC3F3F4-93EF-461F-9834-6CDFB09E6827}"/>
               </a:ext>
             </a:extLst>
           </p:cNvPr>
@@ -1605,18 +1605,18 @@
           <p:cNvPr id="16" name="symbolic-detail-0">
             <a:extLst xmlns:a="http://schemas.openxmlformats.org/drawingml/2006/main">
               <a:ext uri="{FF2B5EF4-FFF2-40B4-BE49-F238E27FC236}">
-                <a16:creationId xmlns:a16="http://schemas.microsoft.com/office/drawing/2014/main" id="{D2E1E300-A0CA-4EB6-B8A3-1B74861A4803}"/>
-              </a:ext>
-            </a:extLst>
-          </p:cNvPr>
-          <p:cNvSpPr>
-            <a:spLocks xmlns:a="http://schemas.openxmlformats.org/drawingml/2006/main" noGrp="1"/>
-          </p:cNvSpPr>
-          <p:nvPr/>
-        </p:nvSpPr>
-        <p:spPr>
-          <a:xfrm xmlns:a="http://schemas.openxmlformats.org/drawingml/2006/main">
-            <a:off x="495300" y="1428750"/>
+                <a16:creationId xmlns:a16="http://schemas.microsoft.com/office/drawing/2014/main" id="{971EE153-1D44-495F-91F4-BA2EC8EE30F5}"/>
+              </a:ext>
+            </a:extLst>
+          </p:cNvPr>
+          <p:cNvSpPr>
+            <a:spLocks xmlns:a="http://schemas.openxmlformats.org/drawingml/2006/main" noGrp="1"/>
+          </p:cNvSpPr>
+          <p:nvPr/>
+        </p:nvSpPr>
+        <p:spPr>
+          <a:xfrm xmlns:a="http://schemas.openxmlformats.org/drawingml/2006/main">
+            <a:off x="495300" y="1371600"/>
             <a:ext cx="3009900" cy="257175"/>
           </a:xfrm>
           <a:prstGeom xmlns:a="http://schemas.openxmlformats.org/drawingml/2006/main" prst="rect">
@@ -1652,6 +1652,63 @@
                 <a:ea typeface="Arial"/>
                 <a:cs typeface="Arial"/>
               </a:rPr>
+              <a:t>e.g., SAX, SAA-SAX</a:t>
+            </a:r>
+          </a:p>
+        </p:txBody>
+      </p:sp>
+      <p:sp>
+        <p:nvSpPr>
+          <p:cNvPr id="17" name="symbolic-detail-1">
+            <a:extLst xmlns:a="http://schemas.openxmlformats.org/drawingml/2006/main">
+              <a:ext uri="{FF2B5EF4-FFF2-40B4-BE49-F238E27FC236}">
+                <a16:creationId xmlns:a16="http://schemas.microsoft.com/office/drawing/2014/main" id="{0B5E98EB-2588-458F-89C4-1499DB3CBCDA}"/>
+              </a:ext>
+            </a:extLst>
+          </p:cNvPr>
+          <p:cNvSpPr>
+            <a:spLocks xmlns:a="http://schemas.openxmlformats.org/drawingml/2006/main" noGrp="1"/>
+          </p:cNvSpPr>
+          <p:nvPr/>
+        </p:nvSpPr>
+        <p:spPr>
+          <a:xfrm xmlns:a="http://schemas.openxmlformats.org/drawingml/2006/main">
+            <a:off x="495300" y="1647825"/>
+            <a:ext cx="3009900" cy="257175"/>
+          </a:xfrm>
+          <a:prstGeom xmlns:a="http://schemas.openxmlformats.org/drawingml/2006/main" prst="rect">
+            <a:avLst/>
+          </a:prstGeom>
+          <a:noFill xmlns:a="http://schemas.openxmlformats.org/drawingml/2006/main"/>
+          <a:ln xmlns:a="http://schemas.openxmlformats.org/drawingml/2006/main" w="0">
+            <a:noFill/>
+          </a:ln>
+        </p:spPr>
+        <p:txBody>
+          <a:bodyPr xmlns:a="http://schemas.openxmlformats.org/drawingml/2006/main" wrap="none" lIns="0" tIns="0" rIns="0" bIns="0" anchor="ctr">
+            <a:noAutofit/>
+          </a:bodyPr>
+          <a:lstStyle xmlns:a="http://schemas.openxmlformats.org/drawingml/2006/main"/>
+          <a:p xmlns:a="http://schemas.openxmlformats.org/drawingml/2006/main">
+            <a:pPr algn="ctr">
+              <a:defRPr sz="1575" b="0">
+                <a:solidFill>
+                  <a:srgbClr val="000000"/>
+                </a:solidFill>
+                <a:latin typeface="Arial"/>
+                <a:ea typeface="Arial"/>
+                <a:cs typeface="Arial"/>
+              </a:defRPr>
+            </a:pPr>
+            <a:r>
+              <a:rPr sz="1575" b="0">
+                <a:solidFill>
+                  <a:srgbClr val="000000"/>
+                </a:solidFill>
+                <a:latin typeface="Arial"/>
+                <a:ea typeface="Arial"/>
+                <a:cs typeface="Arial"/>
+              </a:rPr>
               <a:t>Temporal tokenization</a:t>
             </a:r>
           </a:p>
@@ -1659,10 +1716,10 @@
       </p:sp>
       <p:sp>
         <p:nvSpPr>
-          <p:cNvPr id="17" name="compression">
-            <a:extLst xmlns:a="http://schemas.openxmlformats.org/drawingml/2006/main">
-              <a:ext uri="{FF2B5EF4-FFF2-40B4-BE49-F238E27FC236}">
-                <a16:creationId xmlns:a16="http://schemas.microsoft.com/office/drawing/2014/main" id="{F8475F2A-8CA7-4782-9DEC-84F4937BE53E}"/>
+          <p:cNvPr id="18" name="compression">
+            <a:extLst xmlns:a="http://schemas.openxmlformats.org/drawingml/2006/main">
+              <a:ext uri="{FF2B5EF4-FFF2-40B4-BE49-F238E27FC236}">
+                <a16:creationId xmlns:a16="http://schemas.microsoft.com/office/drawing/2014/main" id="{6BCA0279-A424-40DA-95F8-9820E782130C}"/>
               </a:ext>
             </a:extLst>
           </p:cNvPr>
@@ -1692,21 +1749,21 @@
       </p:sp>
       <p:sp>
         <p:nvSpPr>
-          <p:cNvPr id="18" name="compression-label">
-            <a:extLst xmlns:a="http://schemas.openxmlformats.org/drawingml/2006/main">
-              <a:ext uri="{FF2B5EF4-FFF2-40B4-BE49-F238E27FC236}">
-                <a16:creationId xmlns:a16="http://schemas.microsoft.com/office/drawing/2014/main" id="{DE200622-23F9-4BEF-8E57-B7D384205493}"/>
-              </a:ext>
-            </a:extLst>
-          </p:cNvPr>
-          <p:cNvSpPr>
-            <a:spLocks xmlns:a="http://schemas.openxmlformats.org/drawingml/2006/main" noGrp="1"/>
-          </p:cNvSpPr>
-          <p:nvPr/>
-        </p:nvSpPr>
-        <p:spPr>
-          <a:xfrm xmlns:a="http://schemas.openxmlformats.org/drawingml/2006/main">
-            <a:off x="495300" y="3138488"/>
+          <p:cNvPr id="19" name="compression-label">
+            <a:extLst xmlns:a="http://schemas.openxmlformats.org/drawingml/2006/main">
+              <a:ext uri="{FF2B5EF4-FFF2-40B4-BE49-F238E27FC236}">
+                <a16:creationId xmlns:a16="http://schemas.microsoft.com/office/drawing/2014/main" id="{816C9DA9-0B88-4537-8A29-0FF7A518F3CA}"/>
+              </a:ext>
+            </a:extLst>
+          </p:cNvPr>
+          <p:cNvSpPr>
+            <a:spLocks xmlns:a="http://schemas.openxmlformats.org/drawingml/2006/main" noGrp="1"/>
+          </p:cNvSpPr>
+          <p:nvPr/>
+        </p:nvSpPr>
+        <p:spPr>
+          <a:xfrm xmlns:a="http://schemas.openxmlformats.org/drawingml/2006/main">
+            <a:off x="495300" y="2847975"/>
             <a:ext cx="3009900" cy="342900"/>
           </a:xfrm>
           <a:prstGeom xmlns:a="http://schemas.openxmlformats.org/drawingml/2006/main" prst="rect">
@@ -1749,10 +1806,124 @@
       </p:sp>
       <p:sp>
         <p:nvSpPr>
-          <p:cNvPr id="19" name="frequency">
-            <a:extLst xmlns:a="http://schemas.openxmlformats.org/drawingml/2006/main">
-              <a:ext uri="{FF2B5EF4-FFF2-40B4-BE49-F238E27FC236}">
-                <a16:creationId xmlns:a16="http://schemas.microsoft.com/office/drawing/2014/main" id="{B87BCE35-2139-446F-BEF7-950C03F910AC}"/>
+          <p:cNvPr id="20" name="compression-detail-0">
+            <a:extLst xmlns:a="http://schemas.openxmlformats.org/drawingml/2006/main">
+              <a:ext uri="{FF2B5EF4-FFF2-40B4-BE49-F238E27FC236}">
+                <a16:creationId xmlns:a16="http://schemas.microsoft.com/office/drawing/2014/main" id="{A84A8E18-9F32-48EB-A1B8-553F5E7D2757}"/>
+              </a:ext>
+            </a:extLst>
+          </p:cNvPr>
+          <p:cNvSpPr>
+            <a:spLocks xmlns:a="http://schemas.openxmlformats.org/drawingml/2006/main" noGrp="1"/>
+          </p:cNvSpPr>
+          <p:nvPr/>
+        </p:nvSpPr>
+        <p:spPr>
+          <a:xfrm xmlns:a="http://schemas.openxmlformats.org/drawingml/2006/main">
+            <a:off x="495300" y="3276600"/>
+            <a:ext cx="3009900" cy="257175"/>
+          </a:xfrm>
+          <a:prstGeom xmlns:a="http://schemas.openxmlformats.org/drawingml/2006/main" prst="rect">
+            <a:avLst/>
+          </a:prstGeom>
+          <a:noFill xmlns:a="http://schemas.openxmlformats.org/drawingml/2006/main"/>
+          <a:ln xmlns:a="http://schemas.openxmlformats.org/drawingml/2006/main" w="0">
+            <a:noFill/>
+          </a:ln>
+        </p:spPr>
+        <p:txBody>
+          <a:bodyPr xmlns:a="http://schemas.openxmlformats.org/drawingml/2006/main" wrap="none" lIns="0" tIns="0" rIns="0" bIns="0" anchor="ctr">
+            <a:noAutofit/>
+          </a:bodyPr>
+          <a:lstStyle xmlns:a="http://schemas.openxmlformats.org/drawingml/2006/main"/>
+          <a:p xmlns:a="http://schemas.openxmlformats.org/drawingml/2006/main">
+            <a:pPr algn="ctr">
+              <a:defRPr sz="1575" b="0">
+                <a:solidFill>
+                  <a:srgbClr val="000000"/>
+                </a:solidFill>
+                <a:latin typeface="Arial"/>
+                <a:ea typeface="Arial"/>
+                <a:cs typeface="Arial"/>
+              </a:defRPr>
+            </a:pPr>
+            <a:r>
+              <a:rPr sz="1575" b="0">
+                <a:solidFill>
+                  <a:srgbClr val="000000"/>
+                </a:solidFill>
+                <a:latin typeface="Arial"/>
+                <a:ea typeface="Arial"/>
+                <a:cs typeface="Arial"/>
+              </a:rPr>
+              <a:t>Aggregation and approximation</a:t>
+            </a:r>
+          </a:p>
+        </p:txBody>
+      </p:sp>
+      <p:sp>
+        <p:nvSpPr>
+          <p:cNvPr id="21" name="compression-detail-1">
+            <a:extLst xmlns:a="http://schemas.openxmlformats.org/drawingml/2006/main">
+              <a:ext uri="{FF2B5EF4-FFF2-40B4-BE49-F238E27FC236}">
+                <a16:creationId xmlns:a16="http://schemas.microsoft.com/office/drawing/2014/main" id="{AB877DB0-AE5E-44B0-AB6F-8B1524368C48}"/>
+              </a:ext>
+            </a:extLst>
+          </p:cNvPr>
+          <p:cNvSpPr>
+            <a:spLocks xmlns:a="http://schemas.openxmlformats.org/drawingml/2006/main" noGrp="1"/>
+          </p:cNvSpPr>
+          <p:nvPr/>
+        </p:nvSpPr>
+        <p:spPr>
+          <a:xfrm xmlns:a="http://schemas.openxmlformats.org/drawingml/2006/main">
+            <a:off x="495300" y="3552825"/>
+            <a:ext cx="3009900" cy="257175"/>
+          </a:xfrm>
+          <a:prstGeom xmlns:a="http://schemas.openxmlformats.org/drawingml/2006/main" prst="rect">
+            <a:avLst/>
+          </a:prstGeom>
+          <a:noFill xmlns:a="http://schemas.openxmlformats.org/drawingml/2006/main"/>
+          <a:ln xmlns:a="http://schemas.openxmlformats.org/drawingml/2006/main" w="0">
+            <a:noFill/>
+          </a:ln>
+        </p:spPr>
+        <p:txBody>
+          <a:bodyPr xmlns:a="http://schemas.openxmlformats.org/drawingml/2006/main" wrap="none" lIns="0" tIns="0" rIns="0" bIns="0" anchor="ctr">
+            <a:noAutofit/>
+          </a:bodyPr>
+          <a:lstStyle xmlns:a="http://schemas.openxmlformats.org/drawingml/2006/main"/>
+          <a:p xmlns:a="http://schemas.openxmlformats.org/drawingml/2006/main">
+            <a:pPr algn="ctr">
+              <a:defRPr sz="1575" b="0">
+                <a:solidFill>
+                  <a:srgbClr val="000000"/>
+                </a:solidFill>
+                <a:latin typeface="Arial"/>
+                <a:ea typeface="Arial"/>
+                <a:cs typeface="Arial"/>
+              </a:defRPr>
+            </a:pPr>
+            <a:r>
+              <a:rPr sz="1575" b="0">
+                <a:solidFill>
+                  <a:srgbClr val="000000"/>
+                </a:solidFill>
+                <a:latin typeface="Arial"/>
+                <a:ea typeface="Arial"/>
+                <a:cs typeface="Arial"/>
+              </a:rPr>
+              <a:t>e.g., PAA, SAX, SAA-SAX</a:t>
+            </a:r>
+          </a:p>
+        </p:txBody>
+      </p:sp>
+      <p:sp>
+        <p:nvSpPr>
+          <p:cNvPr id="22" name="frequency">
+            <a:extLst xmlns:a="http://schemas.openxmlformats.org/drawingml/2006/main">
+              <a:ext uri="{FF2B5EF4-FFF2-40B4-BE49-F238E27FC236}">
+                <a16:creationId xmlns:a16="http://schemas.microsoft.com/office/drawing/2014/main" id="{FB5F2FCA-8CFF-495E-B92D-F018F03E7792}"/>
               </a:ext>
             </a:extLst>
           </p:cNvPr>
@@ -1782,10 +1953,10 @@
       </p:sp>
       <p:sp>
         <p:nvSpPr>
-          <p:cNvPr id="20" name="frequency-label">
-            <a:extLst xmlns:a="http://schemas.openxmlformats.org/drawingml/2006/main">
-              <a:ext uri="{FF2B5EF4-FFF2-40B4-BE49-F238E27FC236}">
-                <a16:creationId xmlns:a16="http://schemas.microsoft.com/office/drawing/2014/main" id="{78EF1FAE-1341-41D2-9C1C-C836C00D7859}"/>
+          <p:cNvPr id="23" name="frequency-label">
+            <a:extLst xmlns:a="http://schemas.openxmlformats.org/drawingml/2006/main">
+              <a:ext uri="{FF2B5EF4-FFF2-40B4-BE49-F238E27FC236}">
+                <a16:creationId xmlns:a16="http://schemas.microsoft.com/office/drawing/2014/main" id="{38A63B3E-E111-4AA0-B365-C74B452590FA}"/>
               </a:ext>
             </a:extLst>
           </p:cNvPr>
@@ -1839,10 +2010,10 @@
       </p:sp>
       <p:sp>
         <p:nvSpPr>
-          <p:cNvPr id="21" name="similarity">
-            <a:extLst xmlns:a="http://schemas.openxmlformats.org/drawingml/2006/main">
-              <a:ext uri="{FF2B5EF4-FFF2-40B4-BE49-F238E27FC236}">
-                <a16:creationId xmlns:a16="http://schemas.microsoft.com/office/drawing/2014/main" id="{9E44A7CE-F0A3-4830-87C9-343877383711}"/>
+          <p:cNvPr id="24" name="similarity">
+            <a:extLst xmlns:a="http://schemas.openxmlformats.org/drawingml/2006/main">
+              <a:ext uri="{FF2B5EF4-FFF2-40B4-BE49-F238E27FC236}">
+                <a16:creationId xmlns:a16="http://schemas.microsoft.com/office/drawing/2014/main" id="{6BDBB74B-BA66-4E57-8356-D59CA7E75D97}"/>
               </a:ext>
             </a:extLst>
           </p:cNvPr>
@@ -1872,10 +2043,10 @@
       </p:sp>
       <p:sp>
         <p:nvSpPr>
-          <p:cNvPr id="22" name="similarity-label">
-            <a:extLst xmlns:a="http://schemas.openxmlformats.org/drawingml/2006/main">
-              <a:ext uri="{FF2B5EF4-FFF2-40B4-BE49-F238E27FC236}">
-                <a16:creationId xmlns:a16="http://schemas.microsoft.com/office/drawing/2014/main" id="{F3A3A82D-8E92-47CE-B796-D36D06DD807B}"/>
+          <p:cNvPr id="25" name="similarity-label">
+            <a:extLst xmlns:a="http://schemas.openxmlformats.org/drawingml/2006/main">
+              <a:ext uri="{FF2B5EF4-FFF2-40B4-BE49-F238E27FC236}">
+                <a16:creationId xmlns:a16="http://schemas.microsoft.com/office/drawing/2014/main" id="{62AFE795-93E0-4072-BB82-216B3D3595CD}"/>
               </a:ext>
             </a:extLst>
           </p:cNvPr>
@@ -1929,10 +2100,10 @@
       </p:sp>
       <p:sp>
         <p:nvSpPr>
-          <p:cNvPr id="23" name="similarity-detail-0">
-            <a:extLst xmlns:a="http://schemas.openxmlformats.org/drawingml/2006/main">
-              <a:ext uri="{FF2B5EF4-FFF2-40B4-BE49-F238E27FC236}">
-                <a16:creationId xmlns:a16="http://schemas.microsoft.com/office/drawing/2014/main" id="{F55159F0-1E2C-439A-B8BC-91A2629E75BC}"/>
+          <p:cNvPr id="26" name="similarity-detail-0">
+            <a:extLst xmlns:a="http://schemas.openxmlformats.org/drawingml/2006/main">
+              <a:ext uri="{FF2B5EF4-FFF2-40B4-BE49-F238E27FC236}">
+                <a16:creationId xmlns:a16="http://schemas.microsoft.com/office/drawing/2014/main" id="{6BD6B866-DD7C-4204-A2C1-60815907FC45}"/>
               </a:ext>
             </a:extLst>
           </p:cNvPr>
@@ -1986,10 +2157,10 @@
       </p:sp>
       <p:sp>
         <p:nvSpPr>
-          <p:cNvPr id="24" name="forecasting">
-            <a:extLst xmlns:a="http://schemas.openxmlformats.org/drawingml/2006/main">
-              <a:ext uri="{FF2B5EF4-FFF2-40B4-BE49-F238E27FC236}">
-                <a16:creationId xmlns:a16="http://schemas.microsoft.com/office/drawing/2014/main" id="{61D9BD4E-57B5-4146-88FB-44284D0B1710}"/>
+          <p:cNvPr id="27" name="forecasting">
+            <a:extLst xmlns:a="http://schemas.openxmlformats.org/drawingml/2006/main">
+              <a:ext uri="{FF2B5EF4-FFF2-40B4-BE49-F238E27FC236}">
+                <a16:creationId xmlns:a16="http://schemas.microsoft.com/office/drawing/2014/main" id="{8E3FC92D-19CF-45EB-98D0-5F5E6604BBC8}"/>
               </a:ext>
             </a:extLst>
           </p:cNvPr>
@@ -2019,10 +2190,10 @@
       </p:sp>
       <p:sp>
         <p:nvSpPr>
-          <p:cNvPr id="25" name="forecasting-label">
-            <a:extLst xmlns:a="http://schemas.openxmlformats.org/drawingml/2006/main">
-              <a:ext uri="{FF2B5EF4-FFF2-40B4-BE49-F238E27FC236}">
-                <a16:creationId xmlns:a16="http://schemas.microsoft.com/office/drawing/2014/main" id="{7A5C3443-C5B0-4BDD-83EC-14FFF9E1A21F}"/>
+          <p:cNvPr id="28" name="forecasting-label">
+            <a:extLst xmlns:a="http://schemas.openxmlformats.org/drawingml/2006/main">
+              <a:ext uri="{FF2B5EF4-FFF2-40B4-BE49-F238E27FC236}">
+                <a16:creationId xmlns:a16="http://schemas.microsoft.com/office/drawing/2014/main" id="{B5EC96EC-E6FB-443B-B4E1-E989FD59A5C9}"/>
               </a:ext>
             </a:extLst>
           </p:cNvPr>
@@ -2076,10 +2247,10 @@
       </p:sp>
       <p:sp>
         <p:nvSpPr>
-          <p:cNvPr id="26" name="forecasting-detail-0">
-            <a:extLst xmlns:a="http://schemas.openxmlformats.org/drawingml/2006/main">
-              <a:ext uri="{FF2B5EF4-FFF2-40B4-BE49-F238E27FC236}">
-                <a16:creationId xmlns:a16="http://schemas.microsoft.com/office/drawing/2014/main" id="{DA3D25DC-0B54-4B81-902C-4B2C4C087350}"/>
+          <p:cNvPr id="29" name="forecasting-detail-0">
+            <a:extLst xmlns:a="http://schemas.openxmlformats.org/drawingml/2006/main">
+              <a:ext uri="{FF2B5EF4-FFF2-40B4-BE49-F238E27FC236}">
+                <a16:creationId xmlns:a16="http://schemas.microsoft.com/office/drawing/2014/main" id="{878AFE96-9F6A-4163-969A-DD7C7172DCC8}"/>
               </a:ext>
             </a:extLst>
           </p:cNvPr>
@@ -2133,10 +2304,10 @@
       </p:sp>
       <p:sp>
         <p:nvSpPr>
-          <p:cNvPr id="27" name="forecasting-detail-1">
-            <a:extLst xmlns:a="http://schemas.openxmlformats.org/drawingml/2006/main">
-              <a:ext uri="{FF2B5EF4-FFF2-40B4-BE49-F238E27FC236}">
-                <a16:creationId xmlns:a16="http://schemas.microsoft.com/office/drawing/2014/main" id="{0AA4B695-8A44-4D52-BC77-4934E7BB2242}"/>
+          <p:cNvPr id="30" name="forecasting-detail-1">
+            <a:extLst xmlns:a="http://schemas.openxmlformats.org/drawingml/2006/main">
+              <a:ext uri="{FF2B5EF4-FFF2-40B4-BE49-F238E27FC236}">
+                <a16:creationId xmlns:a16="http://schemas.microsoft.com/office/drawing/2014/main" id="{7557BB4A-1DD0-4388-92EB-B21DE78F1314}"/>
               </a:ext>
             </a:extLst>
           </p:cNvPr>
@@ -2190,10 +2361,10 @@
       </p:sp>
       <p:sp>
         <p:nvSpPr>
-          <p:cNvPr id="28" name="classification">
-            <a:extLst xmlns:a="http://schemas.openxmlformats.org/drawingml/2006/main">
-              <a:ext uri="{FF2B5EF4-FFF2-40B4-BE49-F238E27FC236}">
-                <a16:creationId xmlns:a16="http://schemas.microsoft.com/office/drawing/2014/main" id="{E75279EB-EDD1-47F9-91B6-0278FC8C99DE}"/>
+          <p:cNvPr id="31" name="classification">
+            <a:extLst xmlns:a="http://schemas.openxmlformats.org/drawingml/2006/main">
+              <a:ext uri="{FF2B5EF4-FFF2-40B4-BE49-F238E27FC236}">
+                <a16:creationId xmlns:a16="http://schemas.microsoft.com/office/drawing/2014/main" id="{DD9747FB-F239-45EC-8068-E14B4E7F69CB}"/>
               </a:ext>
             </a:extLst>
           </p:cNvPr>
@@ -2223,10 +2394,10 @@
       </p:sp>
       <p:sp>
         <p:nvSpPr>
-          <p:cNvPr id="29" name="classification-label">
-            <a:extLst xmlns:a="http://schemas.openxmlformats.org/drawingml/2006/main">
-              <a:ext uri="{FF2B5EF4-FFF2-40B4-BE49-F238E27FC236}">
-                <a16:creationId xmlns:a16="http://schemas.microsoft.com/office/drawing/2014/main" id="{26FDD168-116A-4D8E-A2D7-194915196BAE}"/>
+          <p:cNvPr id="32" name="classification-label">
+            <a:extLst xmlns:a="http://schemas.openxmlformats.org/drawingml/2006/main">
+              <a:ext uri="{FF2B5EF4-FFF2-40B4-BE49-F238E27FC236}">
+                <a16:creationId xmlns:a16="http://schemas.microsoft.com/office/drawing/2014/main" id="{5D6715FD-3C8A-4C54-9032-6C379B92190C}"/>
               </a:ext>
             </a:extLst>
           </p:cNvPr>
@@ -2280,10 +2451,10 @@
       </p:sp>
       <p:sp>
         <p:nvSpPr>
-          <p:cNvPr id="30" name="classification-detail-0">
-            <a:extLst xmlns:a="http://schemas.openxmlformats.org/drawingml/2006/main">
-              <a:ext uri="{FF2B5EF4-FFF2-40B4-BE49-F238E27FC236}">
-                <a16:creationId xmlns:a16="http://schemas.microsoft.com/office/drawing/2014/main" id="{7FEB3219-DDC3-4538-A903-1D6CCF2631FF}"/>
+          <p:cNvPr id="33" name="classification-detail-0">
+            <a:extLst xmlns:a="http://schemas.openxmlformats.org/drawingml/2006/main">
+              <a:ext uri="{FF2B5EF4-FFF2-40B4-BE49-F238E27FC236}">
+                <a16:creationId xmlns:a16="http://schemas.microsoft.com/office/drawing/2014/main" id="{71FC8874-464F-4737-88FA-586E1DD5D473}"/>
               </a:ext>
             </a:extLst>
           </p:cNvPr>
@@ -2337,10 +2508,10 @@
       </p:sp>
       <p:sp>
         <p:nvSpPr>
-          <p:cNvPr id="31" name="decomposition">
-            <a:extLst xmlns:a="http://schemas.openxmlformats.org/drawingml/2006/main">
-              <a:ext uri="{FF2B5EF4-FFF2-40B4-BE49-F238E27FC236}">
-                <a16:creationId xmlns:a16="http://schemas.microsoft.com/office/drawing/2014/main" id="{505564E5-45C5-48C0-8720-9E24BA9C36F7}"/>
+          <p:cNvPr id="34" name="decomposition">
+            <a:extLst xmlns:a="http://schemas.openxmlformats.org/drawingml/2006/main">
+              <a:ext uri="{FF2B5EF4-FFF2-40B4-BE49-F238E27FC236}">
+                <a16:creationId xmlns:a16="http://schemas.microsoft.com/office/drawing/2014/main" id="{0DE5A755-2089-4416-BCF1-2B85F5250C23}"/>
               </a:ext>
             </a:extLst>
           </p:cNvPr>
@@ -2370,10 +2541,10 @@
       </p:sp>
       <p:sp>
         <p:nvSpPr>
-          <p:cNvPr id="32" name="decomposition-label">
-            <a:extLst xmlns:a="http://schemas.openxmlformats.org/drawingml/2006/main">
-              <a:ext uri="{FF2B5EF4-FFF2-40B4-BE49-F238E27FC236}">
-                <a16:creationId xmlns:a16="http://schemas.microsoft.com/office/drawing/2014/main" id="{E633390D-CC9E-402B-8E37-8F09F7DFB2A7}"/>
+          <p:cNvPr id="35" name="decomposition-label">
+            <a:extLst xmlns:a="http://schemas.openxmlformats.org/drawingml/2006/main">
+              <a:ext uri="{FF2B5EF4-FFF2-40B4-BE49-F238E27FC236}">
+                <a16:creationId xmlns:a16="http://schemas.microsoft.com/office/drawing/2014/main" id="{1F0DA29E-3723-4D62-B7B7-420873747538}"/>
               </a:ext>
             </a:extLst>
           </p:cNvPr>
@@ -2427,10 +2598,10 @@
       </p:sp>
       <p:sp>
         <p:nvSpPr>
-          <p:cNvPr id="33" name="decomposition-detail-0">
-            <a:extLst xmlns:a="http://schemas.openxmlformats.org/drawingml/2006/main">
-              <a:ext uri="{FF2B5EF4-FFF2-40B4-BE49-F238E27FC236}">
-                <a16:creationId xmlns:a16="http://schemas.microsoft.com/office/drawing/2014/main" id="{324CD105-CD5D-4B58-B192-D2FC47C01691}"/>
+          <p:cNvPr id="36" name="decomposition-detail-0">
+            <a:extLst xmlns:a="http://schemas.openxmlformats.org/drawingml/2006/main">
+              <a:ext uri="{FF2B5EF4-FFF2-40B4-BE49-F238E27FC236}">
+                <a16:creationId xmlns:a16="http://schemas.microsoft.com/office/drawing/2014/main" id="{91ACD5F2-714F-4D7E-9F95-B9E0645AC7B6}"/>
               </a:ext>
             </a:extLst>
           </p:cNvPr>
@@ -2484,10 +2655,10 @@
       </p:sp>
       <p:sp>
         <p:nvSpPr>
-          <p:cNvPr id="34" name="decomposition-detail-1">
-            <a:extLst xmlns:a="http://schemas.openxmlformats.org/drawingml/2006/main">
-              <a:ext uri="{FF2B5EF4-FFF2-40B4-BE49-F238E27FC236}">
-                <a16:creationId xmlns:a16="http://schemas.microsoft.com/office/drawing/2014/main" id="{507FF84B-7BE9-46D6-A284-7FF2C629AD44}"/>
+          <p:cNvPr id="37" name="decomposition-detail-1">
+            <a:extLst xmlns:a="http://schemas.openxmlformats.org/drawingml/2006/main">
+              <a:ext uri="{FF2B5EF4-FFF2-40B4-BE49-F238E27FC236}">
+                <a16:creationId xmlns:a16="http://schemas.microsoft.com/office/drawing/2014/main" id="{C9DAE67D-E040-402D-BC93-878A2887249A}"/>
               </a:ext>
             </a:extLst>
           </p:cNvPr>
@@ -2542,7 +2713,7 @@
     </p:spTree>
     <p:extLst>
       <p:ext uri="{BB962C8B-B14F-4D97-AF65-F5344CB8AC3E}">
-        <p14:creationId xmlns:p14="http://schemas.microsoft.com/office/powerpoint/2010/main" val="1581558783"/>
+        <p14:creationId xmlns:p14="http://schemas.microsoft.com/office/powerpoint/2010/main" val="777473811"/>
       </p:ext>
     </p:extLst>
   </p:cSld>

</xml_diff>